<commit_message>
Pitch deck: slide 11 Offer Reality Check uses the same basket as the screenshots (LKR 259 headline, pays LKR 0); PDF re-exported
Co-authored-by: Cursor <cursoragent@cursor.com>
</commit_message>
<xml_diff>
--- a/docs/submission/Savvy-Cart-AI-gTaprobane-Pitch-Deck.pptx
+++ b/docs/submission/Savvy-Cart-AI-gTaprobane-Pitch-Deck.pptx
@@ -7932,25 +7932,7 @@
                 <a:cs typeface="Google Sans Flex Medium"/>
                 <a:sym typeface="Google Sans Flex Medium"/>
               </a:rPr>
-              <a:t> shelf price (LKR 2,597</a:t>
-            </a:r>
-            <a:r>
-              <a:rPr lang="en-US">
-                <a:latin typeface="Google Sans Flex Medium"/>
-                <a:ea typeface="Google Sans Flex Medium"/>
-                <a:cs typeface="Google Sans Flex Medium"/>
-                <a:sym typeface="Google Sans Flex Medium"/>
-              </a:rPr>
-              <a:t>); all of </a:t>
-            </a:r>
-            <a:r>
-              <a:rPr lang="en-US" dirty="0">
-                <a:latin typeface="Google Sans Flex Medium"/>
-                <a:ea typeface="Google Sans Flex Medium"/>
-                <a:cs typeface="Google Sans Flex Medium"/>
-                <a:sym typeface="Google Sans Flex Medium"/>
-              </a:rPr>
-              <a:t>that comes from store promotions. Two stores were allowed, but </a:t>
+              <a:t> shelf price (LKR 2,597); all of that comes from store promotions. Two stores were allowed, but </a:t>
             </a:r>
             <a:r>
               <a:rPr lang="en-US" dirty="0" err="1">
@@ -8023,7 +8005,7 @@
                 <a:cs typeface="Google Sans Flex Medium"/>
                 <a:sym typeface="Google Sans Flex Medium"/>
               </a:rPr>
-              <a:t> Bank's published "10% off every Saturday" suggests LKR 593 off this basket but pays LKR 0. The bill is LKR 2,475 short of the LKR 8,000 minimum</a:t>
+              <a:t> Bank's published "10% off every Saturday" suggests LKR 259 (10% of LKR 2,597) but pays LKR 0. The bill is LKR 2,190, which is LKR 5,810 short of the LKR 8,000 minimum</a:t>
             </a:r>
           </a:p>
           <a:p>

</xml_diff>